<commit_message>
docs: refresh suite for 28-check demo, authoritative 2026 HHS FPL, step-two workflows (redetermine/overpayment/refer_fraud); fold no-space-path, cmd.exe detached-launch, and stop-orphaned-sign-off-executions lessons into the SA runbook + maintenance
</commit_message>
<xml_diff>
--- a/docs/Benefits-AgentCore-Customer.pptx
+++ b/docs/Benefits-AgentCore-Customer.pptx
@@ -2424,7 +2424,7 @@
                 <a:ea typeface="Calibri" pitchFamily="34" charset="-122"/>
                 <a:cs typeface="Calibri" pitchFamily="34" charset="-120"/>
               </a:rPr>
-              <a:t>Walk your program, privacy, and security teams through the architecture and the live 21-check proof.</a:t>
+              <a:t>Walk your program, privacy, and security teams through the architecture and the live 28-check proof.</a:t>
             </a:r>
             <a:endParaRPr lang="en-US" sz="1230" dirty="0"/>
           </a:p>
@@ -8946,7 +8946,7 @@
                 <a:ea typeface="Cambria" pitchFamily="34" charset="-122"/>
                 <a:cs typeface="Cambria" pitchFamily="34" charset="-120"/>
               </a:rPr>
-              <a:t>21/21</a:t>
+              <a:t>28/28</a:t>
             </a:r>
             <a:endParaRPr lang="en-US" sz="3200" dirty="0"/>
           </a:p>

</xml_diff>

<commit_message>
fix(sign-off) + docs: request_signoff takes validated access_token (P0-5 parity); correct live count to 29/29
Benefits manifest still required 'requester'; live ENFORCE demo failed until fixed, now passes 29/29.
Updated decks/guides/README to the verified 29/29, fixed a stale 'four more checks than PV' note,
and regenerated the .pptx/.docx.
</commit_message>
<xml_diff>
--- a/docs/Benefits-AgentCore-Customer.pptx
+++ b/docs/Benefits-AgentCore-Customer.pptx
@@ -2424,7 +2424,7 @@
                 <a:ea typeface="Calibri" pitchFamily="34" charset="-122"/>
                 <a:cs typeface="Calibri" pitchFamily="34" charset="-120"/>
               </a:rPr>
-              <a:t>Walk your program, privacy, and security teams through the architecture and the live 28-check proof.</a:t>
+              <a:t>Walk your program, privacy, and security teams through the architecture and the live 29-check proof.</a:t>
             </a:r>
             <a:endParaRPr lang="en-US" sz="1230" dirty="0"/>
           </a:p>
@@ -8946,7 +8946,7 @@
                 <a:ea typeface="Cambria" pitchFamily="34" charset="-122"/>
                 <a:cs typeface="Cambria" pitchFamily="34" charset="-120"/>
               </a:rPr>
-              <a:t>28/28</a:t>
+              <a:t>29/29</a:t>
             </a:r>
             <a:endParaRPr lang="en-US" sz="3200" dirty="0"/>
           </a:p>

</xml_diff>